<commit_message>
Remove «40 лет», add 10–25 years specialist-experience messaging; fix nav overlap and chain highlight in web deck
Co-Authored-By: Claude Opus 4.8 <noreply@anthropic.com>
Claude-Session: https://claude.ai/code/session_01Rj4bUHbr45XKBYGjbqAPSW
</commit_message>
<xml_diff>
--- a/gsk-tehnologii.pptx
+++ b/gsk-tehnologii.pptx
@@ -3344,7 +3344,7 @@
                 <a:ea typeface="Arial" pitchFamily="34" charset="-122"/>
                 <a:cs typeface="Arial" pitchFamily="34" charset="-120"/>
               </a:rPr>
-              <a:t>ранее ООО «БМТ»  ·  40 лет на рынке</a:t>
+              <a:t>ранее ООО «БМТ»  ·  специалисты с опытом 10–25 лет</a:t>
             </a:r>
             <a:endParaRPr lang="en-US" sz="1500" dirty="0"/>
           </a:p>
@@ -10684,7 +10684,7 @@
         <p:spPr>
           <a:xfrm>
             <a:off x="548640" y="4114800"/>
-            <a:ext cx="5852160" cy="914400"/>
+            <a:ext cx="5852160" cy="1280160"/>
           </a:xfrm>
           <a:prstGeom prst="rect">
             <a:avLst/>
@@ -10711,7 +10711,7 @@
                 <a:ea typeface="Arial" pitchFamily="34" charset="-122"/>
                 <a:cs typeface="Arial" pitchFamily="34" charset="-120"/>
               </a:rPr>
-              <a:t>Основана в 1985 году. В 2026-м вошла в состав Горно-строительной компании.</a:t>
+              <a:t>Основана в 1985 году, в 2026-м вошла в состав Горно-строительной компании. Инженеры и технологи работают в отрасли по 10–25 лет.</a:t>
             </a:r>
             <a:endParaRPr lang="en-US" sz="1400" dirty="0"/>
           </a:p>
@@ -10775,7 +10775,7 @@
                 <a:ea typeface="Arial" pitchFamily="34" charset="-122"/>
                 <a:cs typeface="Arial" pitchFamily="34" charset="-120"/>
               </a:rPr>
-              <a:t>40</a:t>
+              <a:t>10–25</a:t>
             </a:r>
             <a:endParaRPr lang="en-US" sz="3400" dirty="0"/>
           </a:p>
@@ -10814,7 +10814,7 @@
                 <a:ea typeface="Arial" pitchFamily="34" charset="-122"/>
                 <a:cs typeface="Arial" pitchFamily="34" charset="-120"/>
               </a:rPr>
-              <a:t>лет на рынке</a:t>
+              <a:t>лет опыта у специалистов</a:t>
             </a:r>
             <a:endParaRPr lang="en-US" sz="1300" dirty="0"/>
           </a:p>

</xml_diff>